<commit_message>
fix: regenerate example PPTX with improved native conversion output
</commit_message>
<xml_diff>
--- a/examples/ppt169_顶级咨询风_构建有效AI代理_Anthropic/ppt169_顶级咨询风_构建有效AI代理_Anthropic.pptx
+++ b/examples/ppt169_顶级咨询风_构建有效AI代理_Anthropic/ppt169_顶级咨询风_构建有效AI代理_Anthropic.pptx
@@ -3958,7 +3958,13 @@
           <p:nvPr/>
         </p:nvPicPr>
         <p:blipFill>
-          <a:blip r:embed="rId2"/>
+          <a:blip r:embed="rId2">
+            <a:extLst>
+              <a:ext uri="{96DAC541-7B7A-43D3-8B79-37D633B846F1}">
+                <asvg:svgBlip xmlns:asvg="http://schemas.microsoft.com/office/drawing/2016/SVG/main" r:embed="rId3"/>
+              </a:ext>
+            </a:extLst>
+          </a:blip>
           <a:stretch>
             <a:fillRect/>
           </a:stretch>
@@ -4007,7 +4013,13 @@
           <p:nvPr/>
         </p:nvPicPr>
         <p:blipFill>
-          <a:blip r:embed="rId2"/>
+          <a:blip r:embed="rId2">
+            <a:extLst>
+              <a:ext uri="{96DAC541-7B7A-43D3-8B79-37D633B846F1}">
+                <asvg:svgBlip xmlns:asvg="http://schemas.microsoft.com/office/drawing/2016/SVG/main" r:embed="rId3"/>
+              </a:ext>
+            </a:extLst>
+          </a:blip>
           <a:stretch>
             <a:fillRect/>
           </a:stretch>
@@ -4056,7 +4068,13 @@
           <p:nvPr/>
         </p:nvPicPr>
         <p:blipFill>
-          <a:blip r:embed="rId2"/>
+          <a:blip r:embed="rId2">
+            <a:extLst>
+              <a:ext uri="{96DAC541-7B7A-43D3-8B79-37D633B846F1}">
+                <asvg:svgBlip xmlns:asvg="http://schemas.microsoft.com/office/drawing/2016/SVG/main" r:embed="rId3"/>
+              </a:ext>
+            </a:extLst>
+          </a:blip>
           <a:stretch>
             <a:fillRect/>
           </a:stretch>
@@ -4105,7 +4123,13 @@
           <p:nvPr/>
         </p:nvPicPr>
         <p:blipFill>
-          <a:blip r:embed="rId2"/>
+          <a:blip r:embed="rId2">
+            <a:extLst>
+              <a:ext uri="{96DAC541-7B7A-43D3-8B79-37D633B846F1}">
+                <asvg:svgBlip xmlns:asvg="http://schemas.microsoft.com/office/drawing/2016/SVG/main" r:embed="rId3"/>
+              </a:ext>
+            </a:extLst>
+          </a:blip>
           <a:stretch>
             <a:fillRect/>
           </a:stretch>
@@ -4154,7 +4178,13 @@
           <p:nvPr/>
         </p:nvPicPr>
         <p:blipFill>
-          <a:blip r:embed="rId2"/>
+          <a:blip r:embed="rId2">
+            <a:extLst>
+              <a:ext uri="{96DAC541-7B7A-43D3-8B79-37D633B846F1}">
+                <asvg:svgBlip xmlns:asvg="http://schemas.microsoft.com/office/drawing/2016/SVG/main" r:embed="rId3"/>
+              </a:ext>
+            </a:extLst>
+          </a:blip>
           <a:stretch>
             <a:fillRect/>
           </a:stretch>
@@ -4203,7 +4233,13 @@
           <p:nvPr/>
         </p:nvPicPr>
         <p:blipFill>
-          <a:blip r:embed="rId2"/>
+          <a:blip r:embed="rId2">
+            <a:extLst>
+              <a:ext uri="{96DAC541-7B7A-43D3-8B79-37D633B846F1}">
+                <asvg:svgBlip xmlns:asvg="http://schemas.microsoft.com/office/drawing/2016/SVG/main" r:embed="rId3"/>
+              </a:ext>
+            </a:extLst>
+          </a:blip>
           <a:stretch>
             <a:fillRect/>
           </a:stretch>
@@ -4252,7 +4288,13 @@
           <p:nvPr/>
         </p:nvPicPr>
         <p:blipFill>
-          <a:blip r:embed="rId2"/>
+          <a:blip r:embed="rId2">
+            <a:extLst>
+              <a:ext uri="{96DAC541-7B7A-43D3-8B79-37D633B846F1}">
+                <asvg:svgBlip xmlns:asvg="http://schemas.microsoft.com/office/drawing/2016/SVG/main" r:embed="rId3"/>
+              </a:ext>
+            </a:extLst>
+          </a:blip>
           <a:stretch>
             <a:fillRect/>
           </a:stretch>
@@ -4301,7 +4343,13 @@
           <p:nvPr/>
         </p:nvPicPr>
         <p:blipFill>
-          <a:blip r:embed="rId2"/>
+          <a:blip r:embed="rId2">
+            <a:extLst>
+              <a:ext uri="{96DAC541-7B7A-43D3-8B79-37D633B846F1}">
+                <asvg:svgBlip xmlns:asvg="http://schemas.microsoft.com/office/drawing/2016/SVG/main" r:embed="rId3"/>
+              </a:ext>
+            </a:extLst>
+          </a:blip>
           <a:stretch>
             <a:fillRect/>
           </a:stretch>
@@ -4350,7 +4398,13 @@
           <p:nvPr/>
         </p:nvPicPr>
         <p:blipFill>
-          <a:blip r:embed="rId2"/>
+          <a:blip r:embed="rId2">
+            <a:extLst>
+              <a:ext uri="{96DAC541-7B7A-43D3-8B79-37D633B846F1}">
+                <asvg:svgBlip xmlns:asvg="http://schemas.microsoft.com/office/drawing/2016/SVG/main" r:embed="rId3"/>
+              </a:ext>
+            </a:extLst>
+          </a:blip>
           <a:stretch>
             <a:fillRect/>
           </a:stretch>
@@ -4399,7 +4453,13 @@
           <p:nvPr/>
         </p:nvPicPr>
         <p:blipFill>
-          <a:blip r:embed="rId2"/>
+          <a:blip r:embed="rId2">
+            <a:extLst>
+              <a:ext uri="{96DAC541-7B7A-43D3-8B79-37D633B846F1}">
+                <asvg:svgBlip xmlns:asvg="http://schemas.microsoft.com/office/drawing/2016/SVG/main" r:embed="rId3"/>
+              </a:ext>
+            </a:extLst>
+          </a:blip>
           <a:stretch>
             <a:fillRect/>
           </a:stretch>
@@ -4448,7 +4508,13 @@
           <p:nvPr/>
         </p:nvPicPr>
         <p:blipFill>
-          <a:blip r:embed="rId2"/>
+          <a:blip r:embed="rId2">
+            <a:extLst>
+              <a:ext uri="{96DAC541-7B7A-43D3-8B79-37D633B846F1}">
+                <asvg:svgBlip xmlns:asvg="http://schemas.microsoft.com/office/drawing/2016/SVG/main" r:embed="rId3"/>
+              </a:ext>
+            </a:extLst>
+          </a:blip>
           <a:stretch>
             <a:fillRect/>
           </a:stretch>
@@ -4497,7 +4563,13 @@
           <p:nvPr/>
         </p:nvPicPr>
         <p:blipFill>
-          <a:blip r:embed="rId2"/>
+          <a:blip r:embed="rId2">
+            <a:extLst>
+              <a:ext uri="{96DAC541-7B7A-43D3-8B79-37D633B846F1}">
+                <asvg:svgBlip xmlns:asvg="http://schemas.microsoft.com/office/drawing/2016/SVG/main" r:embed="rId3"/>
+              </a:ext>
+            </a:extLst>
+          </a:blip>
           <a:stretch>
             <a:fillRect/>
           </a:stretch>
@@ -4546,7 +4618,13 @@
           <p:nvPr/>
         </p:nvPicPr>
         <p:blipFill>
-          <a:blip r:embed="rId2"/>
+          <a:blip r:embed="rId2">
+            <a:extLst>
+              <a:ext uri="{96DAC541-7B7A-43D3-8B79-37D633B846F1}">
+                <asvg:svgBlip xmlns:asvg="http://schemas.microsoft.com/office/drawing/2016/SVG/main" r:embed="rId3"/>
+              </a:ext>
+            </a:extLst>
+          </a:blip>
           <a:stretch>
             <a:fillRect/>
           </a:stretch>
@@ -4595,7 +4673,13 @@
           <p:nvPr/>
         </p:nvPicPr>
         <p:blipFill>
-          <a:blip r:embed="rId2"/>
+          <a:blip r:embed="rId2">
+            <a:extLst>
+              <a:ext uri="{96DAC541-7B7A-43D3-8B79-37D633B846F1}">
+                <asvg:svgBlip xmlns:asvg="http://schemas.microsoft.com/office/drawing/2016/SVG/main" r:embed="rId3"/>
+              </a:ext>
+            </a:extLst>
+          </a:blip>
           <a:stretch>
             <a:fillRect/>
           </a:stretch>
@@ -4644,7 +4728,13 @@
           <p:nvPr/>
         </p:nvPicPr>
         <p:blipFill>
-          <a:blip r:embed="rId2"/>
+          <a:blip r:embed="rId2">
+            <a:extLst>
+              <a:ext uri="{96DAC541-7B7A-43D3-8B79-37D633B846F1}">
+                <asvg:svgBlip xmlns:asvg="http://schemas.microsoft.com/office/drawing/2016/SVG/main" r:embed="rId3"/>
+              </a:ext>
+            </a:extLst>
+          </a:blip>
           <a:stretch>
             <a:fillRect/>
           </a:stretch>

</xml_diff>